<commit_message>
Slide 8: remove mission review sheet card
Co-Authored-By: Claude Opus 5.5 <noreply@anthropic.com>
Claude-Session: https://claude.ai/code/session_01Gat5tVsr5NWC6rDktNbfy6
</commit_message>
<xml_diff>
--- a/اجتماع_انطلاق_لجنة_الاعتماد.pptx
+++ b/اجتماع_انطلاق_لجنة_الاعتماد.pptx
@@ -22584,6 +22584,10 @@
             </a:outerShdw>
           </a:effectLst>
         </p:spPr>
+        <p:txBody>
+          <a:bodyPr/>
+          <a:p/>
+        </p:txBody>
       </p:sp>
       <p:sp>
         <p:nvSpPr>
@@ -22609,6 +22613,10 @@
             <a:prstDash val="solid"/>
           </a:ln>
         </p:spPr>
+        <p:txBody>
+          <a:bodyPr/>
+          <a:p/>
+        </p:txBody>
       </p:sp>
       <p:pic>
         <p:nvPicPr>
@@ -22745,6 +22753,10 @@
             </a:outerShdw>
           </a:effectLst>
         </p:spPr>
+        <p:txBody>
+          <a:bodyPr/>
+          <a:p/>
+        </p:txBody>
       </p:sp>
       <p:sp>
         <p:nvSpPr>
@@ -22770,6 +22782,10 @@
             <a:prstDash val="solid"/>
           </a:ln>
         </p:spPr>
+        <p:txBody>
+          <a:bodyPr/>
+          <a:p/>
+        </p:txBody>
       </p:sp>
       <p:pic>
         <p:nvPicPr>
@@ -22906,6 +22922,10 @@
             </a:outerShdw>
           </a:effectLst>
         </p:spPr>
+        <p:txBody>
+          <a:bodyPr/>
+          <a:p/>
+        </p:txBody>
       </p:sp>
       <p:sp>
         <p:nvSpPr>
@@ -22931,6 +22951,10 @@
             <a:prstDash val="solid"/>
           </a:ln>
         </p:spPr>
+        <p:txBody>
+          <a:bodyPr/>
+          <a:p/>
+        </p:txBody>
       </p:sp>
       <p:pic>
         <p:nvPicPr>
@@ -23067,6 +23091,10 @@
             </a:outerShdw>
           </a:effectLst>
         </p:spPr>
+        <p:txBody>
+          <a:bodyPr/>
+          <a:p/>
+        </p:txBody>
       </p:sp>
       <p:sp>
         <p:nvSpPr>
@@ -23092,6 +23120,10 @@
             <a:prstDash val="solid"/>
           </a:ln>
         </p:spPr>
+        <p:txBody>
+          <a:bodyPr/>
+          <a:p/>
+        </p:txBody>
       </p:sp>
       <p:pic>
         <p:nvPicPr>
@@ -23203,7 +23235,7 @@
         </p:nvSpPr>
         <p:spPr>
           <a:xfrm>
-            <a:off x="9018727" y="3154680"/>
+            <a:off x="7633411" y="3154680"/>
             <a:ext cx="2606040" cy="1600200"/>
           </a:xfrm>
           <a:prstGeom prst="roundRect">
@@ -23228,6 +23260,10 @@
             </a:outerShdw>
           </a:effectLst>
         </p:spPr>
+        <p:txBody>
+          <a:bodyPr/>
+          <a:p/>
+        </p:txBody>
       </p:sp>
       <p:sp>
         <p:nvSpPr>
@@ -23237,7 +23273,7 @@
         </p:nvSpPr>
         <p:spPr>
           <a:xfrm>
-            <a:off x="10847527" y="3337560"/>
+            <a:off x="9462211" y="3337560"/>
             <a:ext cx="594360" cy="594360"/>
           </a:xfrm>
           <a:prstGeom prst="ellipse">
@@ -23253,6 +23289,10 @@
             <a:prstDash val="solid"/>
           </a:ln>
         </p:spPr>
+        <p:txBody>
+          <a:bodyPr/>
+          <a:p/>
+        </p:txBody>
       </p:sp>
       <p:pic>
         <p:nvPicPr>
@@ -23270,7 +23310,7 @@
         </p:blipFill>
         <p:spPr>
           <a:xfrm>
-            <a:off x="10996117" y="3486150"/>
+            <a:off x="9610801" y="3486150"/>
             <a:ext cx="297180" cy="297180"/>
           </a:xfrm>
           <a:prstGeom prst="rect">
@@ -23286,7 +23326,7 @@
         </p:nvSpPr>
         <p:spPr>
           <a:xfrm>
-            <a:off x="9201607" y="3401568"/>
+            <a:off x="7816291" y="3401568"/>
             <a:ext cx="1554480" cy="457200"/>
           </a:xfrm>
           <a:prstGeom prst="rect">
@@ -23325,7 +23365,7 @@
         </p:nvSpPr>
         <p:spPr>
           <a:xfrm>
-            <a:off x="9201607" y="4023360"/>
+            <a:off x="7816291" y="4023360"/>
             <a:ext cx="2240280" cy="640080"/>
           </a:xfrm>
           <a:prstGeom prst="rect">
@@ -23364,7 +23404,7 @@
         </p:nvSpPr>
         <p:spPr>
           <a:xfrm>
-            <a:off x="6248095" y="3154680"/>
+            <a:off x="4862779" y="3154680"/>
             <a:ext cx="2606040" cy="1600200"/>
           </a:xfrm>
           <a:prstGeom prst="roundRect">
@@ -23389,6 +23429,10 @@
             </a:outerShdw>
           </a:effectLst>
         </p:spPr>
+        <p:txBody>
+          <a:bodyPr/>
+          <a:p/>
+        </p:txBody>
       </p:sp>
       <p:sp>
         <p:nvSpPr>
@@ -23398,7 +23442,7 @@
         </p:nvSpPr>
         <p:spPr>
           <a:xfrm>
-            <a:off x="8076895" y="3337560"/>
+            <a:off x="6691579" y="3337560"/>
             <a:ext cx="594360" cy="594360"/>
           </a:xfrm>
           <a:prstGeom prst="ellipse">
@@ -23414,6 +23458,10 @@
             <a:prstDash val="solid"/>
           </a:ln>
         </p:spPr>
+        <p:txBody>
+          <a:bodyPr/>
+          <a:p/>
+        </p:txBody>
       </p:sp>
       <p:pic>
         <p:nvPicPr>
@@ -23431,7 +23479,7 @@
         </p:blipFill>
         <p:spPr>
           <a:xfrm>
-            <a:off x="8225485" y="3486150"/>
+            <a:off x="6840169" y="3486150"/>
             <a:ext cx="297180" cy="297180"/>
           </a:xfrm>
           <a:prstGeom prst="rect">
@@ -23447,7 +23495,7 @@
         </p:nvSpPr>
         <p:spPr>
           <a:xfrm>
-            <a:off x="6430975" y="3401568"/>
+            <a:off x="5045659" y="3401568"/>
             <a:ext cx="1554480" cy="457200"/>
           </a:xfrm>
           <a:prstGeom prst="rect">
@@ -23486,7 +23534,7 @@
         </p:nvSpPr>
         <p:spPr>
           <a:xfrm>
-            <a:off x="6430975" y="4023360"/>
+            <a:off x="5045659" y="4023360"/>
             <a:ext cx="2240280" cy="640080"/>
           </a:xfrm>
           <a:prstGeom prst="rect">
@@ -23525,7 +23573,7 @@
         </p:nvSpPr>
         <p:spPr>
           <a:xfrm>
-            <a:off x="3477463" y="3154680"/>
+            <a:off x="2092147" y="3154680"/>
             <a:ext cx="2606040" cy="1600200"/>
           </a:xfrm>
           <a:prstGeom prst="roundRect">
@@ -23550,6 +23598,10 @@
             </a:outerShdw>
           </a:effectLst>
         </p:spPr>
+        <p:txBody>
+          <a:bodyPr/>
+          <a:p/>
+        </p:txBody>
       </p:sp>
       <p:sp>
         <p:nvSpPr>
@@ -23559,7 +23611,7 @@
         </p:nvSpPr>
         <p:spPr>
           <a:xfrm>
-            <a:off x="5306263" y="3337560"/>
+            <a:off x="3920947" y="3337560"/>
             <a:ext cx="594360" cy="594360"/>
           </a:xfrm>
           <a:prstGeom prst="ellipse">
@@ -23575,6 +23627,10 @@
             <a:prstDash val="solid"/>
           </a:ln>
         </p:spPr>
+        <p:txBody>
+          <a:bodyPr/>
+          <a:p/>
+        </p:txBody>
       </p:sp>
       <p:pic>
         <p:nvPicPr>
@@ -23592,7 +23648,7 @@
         </p:blipFill>
         <p:spPr>
           <a:xfrm>
-            <a:off x="5454853" y="3486150"/>
+            <a:off x="4069537" y="3486150"/>
             <a:ext cx="297180" cy="297180"/>
           </a:xfrm>
           <a:prstGeom prst="rect">
@@ -23608,7 +23664,7 @@
         </p:nvSpPr>
         <p:spPr>
           <a:xfrm>
-            <a:off x="3660343" y="3401568"/>
+            <a:off x="2275027" y="3401568"/>
             <a:ext cx="1554480" cy="457200"/>
           </a:xfrm>
           <a:prstGeom prst="rect">
@@ -23647,7 +23703,7 @@
         </p:nvSpPr>
         <p:spPr>
           <a:xfrm>
-            <a:off x="3660343" y="4023360"/>
+            <a:off x="2275027" y="4023360"/>
             <a:ext cx="2240280" cy="640080"/>
           </a:xfrm>
           <a:prstGeom prst="rect">
@@ -23673,167 +23729,6 @@
                 <a:cs typeface="Arial" pitchFamily="34" charset="-120"/>
               </a:rPr>
               <a:t>متطلبات الاعتماد ومكان معالجتها</a:t>
-            </a:r>
-            <a:endParaRPr lang="en-US" sz="1300" dirty="0"/>
-          </a:p>
-        </p:txBody>
-      </p:sp>
-      <p:sp>
-        <p:nvSpPr>
-          <p:cNvPr id="335" name="sheet7"/>
-          <p:cNvSpPr/>
-          <p:nvPr/>
-        </p:nvSpPr>
-        <p:spPr>
-          <a:xfrm>
-            <a:off x="706831" y="3154680"/>
-            <a:ext cx="2606040" cy="1600200"/>
-          </a:xfrm>
-          <a:prstGeom prst="roundRect">
-            <a:avLst>
-              <a:gd name="adj" fmla="val 6857"/>
-            </a:avLst>
-          </a:prstGeom>
-          <a:solidFill>
-            <a:srgbClr val="F7F9FC"/>
-          </a:solidFill>
-          <a:ln w="12700">
-            <a:solidFill>
-              <a:srgbClr val="F7F9FC"/>
-            </a:solidFill>
-            <a:prstDash val="solid"/>
-          </a:ln>
-          <a:effectLst>
-            <a:outerShdw sx="100000" sy="100000" kx="0" ky="0" algn="bl" rotWithShape="0" blurRad="76200" dist="25400" dir="5400000">
-              <a:srgbClr val="9AA8C0">
-                <a:alpha val="25000"/>
-              </a:srgbClr>
-            </a:outerShdw>
-          </a:effectLst>
-        </p:spPr>
-      </p:sp>
-      <p:sp>
-        <p:nvSpPr>
-          <p:cNvPr id="336" name="shIcon7"/>
-          <p:cNvSpPr/>
-          <p:nvPr/>
-        </p:nvSpPr>
-        <p:spPr>
-          <a:xfrm>
-            <a:off x="2535631" y="3337560"/>
-            <a:ext cx="594360" cy="594360"/>
-          </a:xfrm>
-          <a:prstGeom prst="ellipse">
-            <a:avLst/>
-          </a:prstGeom>
-          <a:solidFill>
-            <a:srgbClr val="5E2B91"/>
-          </a:solidFill>
-          <a:ln w="12700">
-            <a:solidFill>
-              <a:srgbClr val="5E2B91"/>
-            </a:solidFill>
-            <a:prstDash val="solid"/>
-          </a:ln>
-        </p:spPr>
-      </p:sp>
-      <p:pic>
-        <p:nvPicPr>
-          <p:cNvPr id="337" name="Image 7" descr="preencoded.png">    </p:cNvPr>
-          <p:cNvPicPr>
-            <a:picLocks noChangeAspect="1"/>
-          </p:cNvPicPr>
-          <p:nvPr/>
-        </p:nvPicPr>
-        <p:blipFill>
-          <a:blip r:embed="rId207"/>
-          <a:stretch>
-            <a:fillRect/>
-          </a:stretch>
-        </p:blipFill>
-        <p:spPr>
-          <a:xfrm>
-            <a:off x="2684221" y="3486150"/>
-            <a:ext cx="297180" cy="297180"/>
-          </a:xfrm>
-          <a:prstGeom prst="rect">
-            <a:avLst/>
-          </a:prstGeom>
-        </p:spPr>
-      </p:pic>
-      <p:sp>
-        <p:nvSpPr>
-          <p:cNvPr id="338" name="Text 31"/>
-          <p:cNvSpPr txBox="1"/>
-          <p:nvPr/>
-        </p:nvSpPr>
-        <p:spPr>
-          <a:xfrm>
-            <a:off x="889711" y="3401568"/>
-            <a:ext cx="1554480" cy="457200"/>
-          </a:xfrm>
-          <a:prstGeom prst="rect">
-            <a:avLst/>
-          </a:prstGeom>
-          <a:noFill/>
-          <a:ln/>
-        </p:spPr>
-        <p:txBody>
-          <a:bodyPr wrap="square" lIns="0" tIns="0" rIns="0" bIns="0" rtlCol="0" anchor="ctr"/>
-          <a:lstStyle/>
-          <a:p>
-            <a:pPr rtl="1" algn="r" indent="0" marL="0">
-              <a:buNone/>
-            </a:pPr>
-            <a:r>
-              <a:rPr lang="en-US" sz="1550" b="1" dirty="0">
-                <a:solidFill>
-                  <a:srgbClr val="5E2B91"/>
-                </a:solidFill>
-                <a:latin typeface="Arial" pitchFamily="34" charset="0"/>
-                <a:ea typeface="Arial" pitchFamily="34" charset="-122"/>
-                <a:cs typeface="Arial" pitchFamily="34" charset="-120"/>
-              </a:rPr>
-              <a:t>مراجعة الرسالة</a:t>
-            </a:r>
-            <a:endParaRPr lang="en-US" sz="1550" dirty="0"/>
-          </a:p>
-        </p:txBody>
-      </p:sp>
-      <p:sp>
-        <p:nvSpPr>
-          <p:cNvPr id="339" name="Text 32"/>
-          <p:cNvSpPr txBox="1"/>
-          <p:nvPr/>
-        </p:nvSpPr>
-        <p:spPr>
-          <a:xfrm>
-            <a:off x="889711" y="4023360"/>
-            <a:ext cx="2240280" cy="640080"/>
-          </a:xfrm>
-          <a:prstGeom prst="rect">
-            <a:avLst/>
-          </a:prstGeom>
-          <a:noFill/>
-          <a:ln/>
-        </p:spPr>
-        <p:txBody>
-          <a:bodyPr wrap="square" lIns="0" tIns="0" rIns="0" bIns="0" rtlCol="0" anchor="t"/>
-          <a:lstStyle/>
-          <a:p>
-            <a:pPr rtl="1" algn="r" indent="0" marL="0">
-              <a:buNone/>
-            </a:pPr>
-            <a:r>
-              <a:rPr lang="en-US" sz="1300" dirty="0">
-                <a:solidFill>
-                  <a:srgbClr val="5A6478"/>
-                </a:solidFill>
-                <a:latin typeface="Arial" pitchFamily="34" charset="0"/>
-                <a:ea typeface="Arial" pitchFamily="34" charset="-122"/>
-                <a:cs typeface="Arial" pitchFamily="34" charset="-120"/>
-              </a:rPr>
-              <a:t>نموذج مقترح للقسم العلمي</a:t>
             </a:r>
             <a:endParaRPr lang="en-US" sz="1300" dirty="0"/>
           </a:p>
@@ -23872,6 +23767,10 @@
             </a:outerShdw>
           </a:effectLst>
         </p:spPr>
+        <p:txBody>
+          <a:bodyPr/>
+          <a:p/>
+        </p:txBody>
       </p:sp>
       <p:sp>
         <p:nvSpPr>

</xml_diff>

<commit_message>
Slide 2: replace evidence count with single unified workbook
Co-Authored-By: Claude Opus 5.5 <noreply@anthropic.com>
Claude-Session: https://claude.ai/code/session_01Gat5tVsr5NWC6rDktNbfy6
</commit_message>
<xml_diff>
--- a/اجتماع_انطلاق_لجنة_الاعتماد.pptx
+++ b/اجتماع_انطلاق_لجنة_الاعتماد.pptx
@@ -1258,12 +1258,12 @@
           </a:p>
           <a:p>
             <a:r>
-              <a:t>عندنا ثلاثة برامج، واللجنة من تسعة أعضاء، ومدة المرحلة الأولى ثمانية أسابيع، وسنفحص فيها ما يقارب ستمئة وأربعة وثلاثين دليلاً.</a:t>
-            </a:r>
-          </a:p>
-          <a:p>
-            <a:r>
-              <a:t>الرقم كبير، لكنه موزع بشكل متوازن على الأعضاء، ومع أداة واضحة سيكون العمل منظماً وسهلاً بإذن الله.</a:t>
+              <a:t>عندنا ثلاثة برامج، واللجنة من تسعة أعضاء، ومدة المرحلة الأولى ثمانية أسابيع.</a:t>
+            </a:r>
+          </a:p>
+          <a:p>
+            <a:r>
+              <a:t>وكل العمل في ملف واحد منظّم، وكل عضو مسؤول عن معيار واحد فقط، فالعمل موزّع وواضح بإذن الله.</a:t>
             </a:r>
           </a:p>
         </p:txBody>
@@ -13379,6 +13379,10 @@
             </a:outerShdw>
           </a:effectLst>
         </p:spPr>
+        <p:txBody>
+          <a:bodyPr/>
+          <a:p/>
+        </p:txBody>
       </p:sp>
       <p:sp>
         <p:nvSpPr>
@@ -13491,6 +13495,10 @@
             </a:outerShdw>
           </a:effectLst>
         </p:spPr>
+        <p:txBody>
+          <a:bodyPr/>
+          <a:p/>
+        </p:txBody>
       </p:sp>
       <p:sp>
         <p:nvSpPr>
@@ -13603,6 +13611,10 @@
             </a:outerShdw>
           </a:effectLst>
         </p:spPr>
+        <p:txBody>
+          <a:bodyPr/>
+          <a:p/>
+        </p:txBody>
       </p:sp>
       <p:sp>
         <p:nvSpPr>
@@ -13715,6 +13727,10 @@
             </a:outerShdw>
           </a:effectLst>
         </p:spPr>
+        <p:txBody>
+          <a:bodyPr/>
+          <a:p/>
+        </p:txBody>
       </p:sp>
       <p:sp>
         <p:nvSpPr>
@@ -13749,7 +13765,7 @@
                 <a:ea typeface="Arial" pitchFamily="34" charset="-122"/>
                 <a:cs typeface="Arial" pitchFamily="34" charset="-120"/>
               </a:rPr>
-              <a:t>634</a:t>
+              <a:t>1</a:t>
             </a:r>
             <a:endParaRPr lang="en-US" sz="5400" dirty="0"/>
           </a:p>
@@ -13788,7 +13804,7 @@
                 <a:ea typeface="Arial" pitchFamily="34" charset="-122"/>
                 <a:cs typeface="Arial" pitchFamily="34" charset="-120"/>
               </a:rPr>
-              <a:t>دليلاً للفحص</a:t>
+              <a:t>ملف عمل موحّد</a:t>
             </a:r>
             <a:endParaRPr lang="en-US" sz="1600" dirty="0"/>
           </a:p>
@@ -13827,6 +13843,10 @@
             </a:outerShdw>
           </a:effectLst>
         </p:spPr>
+        <p:txBody>
+          <a:bodyPr/>
+          <a:p/>
+        </p:txBody>
       </p:sp>
       <p:sp>
         <p:nvSpPr>
@@ -13852,6 +13872,10 @@
             <a:prstDash val="solid"/>
           </a:ln>
         </p:spPr>
+        <p:txBody>
+          <a:bodyPr/>
+          <a:p/>
+        </p:txBody>
       </p:sp>
       <p:pic>
         <p:nvPicPr>

</xml_diff>